<commit_message>
Refresh final presentation artifacts
Ultraworked with [Sisyphus](https://github.com/code-yeongyu/oh-my-opencode)

Co-authored-by: Sisyphus <clio-agent@sisyphuslabs.ai>
</commit_message>
<xml_diff>
--- a/business-plan/presentation/story-lens-public-proposal.pptx
+++ b/business-plan/presentation/story-lens-public-proposal.pptx
@@ -3637,7 +3637,7 @@
                 </a:solidFill>
                 <a:latin typeface="Malgun Gothic"/>
               </a:rPr>
-              <a:t>2026 시범사업 제안서</a:t>
+              <a:t>2026 시범사업 검토안</a:t>
             </a:r>
           </a:p>
         </p:txBody>
@@ -3761,7 +3761,7 @@
       </p:sp>
       <p:pic>
         <p:nvPicPr>
-          <p:cNvPr id="18" name="Picture 17" descr="photobook.png"/>
+          <p:cNvPr id="18" name="Picture 17" descr="home.png"/>
           <p:cNvPicPr>
             <a:picLocks noChangeAspect="1"/>
           </p:cNvPicPr>
@@ -3813,7 +3813,7 @@
                 </a:solidFill>
                 <a:latin typeface="Malgun Gothic"/>
               </a:rPr>
-              <a:t>핵심 제안</a:t>
+              <a:t>사업 개요</a:t>
             </a:r>
           </a:p>
         </p:txBody>
@@ -5797,7 +5797,7 @@
                 </a:solidFill>
                 <a:latin typeface="Malgun Gothic"/>
               </a:rPr>
-              <a:t>공공재원, 협회 운영, 실무팀 실행이 나뉘는 구조</a:t>
+              <a:t>공공재원, 협회 운영, 실무 실행이 나뉘는 구조</a:t>
             </a:r>
           </a:p>
         </p:txBody>
@@ -6888,7 +6888,7 @@
                 </a:solidFill>
                 <a:latin typeface="Malgun Gothic"/>
               </a:rPr>
-              <a:t>제안 결론 및 요청 사항</a:t>
+              <a:t>제안 요약 및 검토 요청</a:t>
             </a:r>
           </a:p>
         </p:txBody>
@@ -7203,7 +7203,7 @@
                 </a:solidFill>
                 <a:latin typeface="Malgun Gothic"/>
               </a:rPr>
-              <a:t>협의 요청</a:t>
+              <a:t>검토 요청 사항</a:t>
             </a:r>
           </a:p>
         </p:txBody>
@@ -7899,7 +7899,7 @@
                 </a:solidFill>
                 <a:latin typeface="Malgun Gothic"/>
               </a:rPr>
-              <a:t>왜 지금 필요한가</a:t>
+              <a:t>추진 배경 및 필요성</a:t>
             </a:r>
           </a:p>
         </p:txBody>
@@ -7934,7 +7934,7 @@
                 </a:solidFill>
                 <a:latin typeface="Malgun Gothic"/>
               </a:rPr>
-              <a:t>꿈꾸는 카메라에서 먼저 검증하고 다른 프로그램으로 확장할 수 있는 디지털 창작 모델</a:t>
+              <a:t>꿈꾸는 카메라에서 우선 검증하고 다른 프로그램으로 확장할 수 있는 디지털 창작 모델</a:t>
             </a:r>
           </a:p>
         </p:txBody>
@@ -9282,7 +9282,7 @@
                 </a:solidFill>
                 <a:latin typeface="Malgun Gothic"/>
               </a:rPr>
-              <a:t>Story Lens가 제공하는 해결 구조</a:t>
+              <a:t>사업 운영 구조</a:t>
             </a:r>
           </a:p>
         </p:txBody>
@@ -10638,7 +10638,7 @@
                 </a:solidFill>
                 <a:latin typeface="Malgun Gothic"/>
               </a:rPr>
-              <a:t>시연용 앱 화면</a:t>
+              <a:t>앱 화면 예시</a:t>
             </a:r>
           </a:p>
         </p:txBody>
@@ -11620,7 +11620,7 @@
                 </a:solidFill>
                 <a:latin typeface="Malgun Gothic"/>
               </a:rPr>
-              <a:t>대상자 중심 설계</a:t>
+              <a:t>참여자 지원 관점</a:t>
             </a:r>
           </a:p>
         </p:txBody>
@@ -14669,7 +14669,7 @@
                 </a:solidFill>
                 <a:latin typeface="Malgun Gothic"/>
               </a:rPr>
-              <a:t>회차별 수업 구성 예시</a:t>
+              <a:t>회기 운영 예시</a:t>
             </a:r>
           </a:p>
         </p:txBody>
@@ -16144,7 +16144,7 @@
                 </a:solidFill>
                 <a:latin typeface="Malgun Gothic"/>
               </a:rPr>
-              <a:t>기대 효과와 산출물</a:t>
+              <a:t>기대 효과 및 산출물</a:t>
             </a:r>
           </a:p>
         </p:txBody>
@@ -16179,7 +16179,7 @@
                 </a:solidFill>
                 <a:latin typeface="Malgun Gothic"/>
               </a:rPr>
-              <a:t>참여자, 가족, 기관 모두에게 남는 결과를 만듭니다.</a:t>
+              <a:t>참여자, 가족, 기관 모두에게 남는 결과를 정리합니다.</a:t>
             </a:r>
           </a:p>
         </p:txBody>
@@ -17356,7 +17356,7 @@
                 </a:solidFill>
                 <a:latin typeface="Malgun Gothic"/>
               </a:rPr>
-              <a:t>시범사업 평가에 바로 연결할 수 있는 기본 지표</a:t>
+              <a:t>시범사업 평가에 활용할 수 있는 기본 지표</a:t>
             </a:r>
           </a:p>
         </p:txBody>

</xml_diff>